<commit_message>
Simplify cover slide to title only; fix bullet indentation across deck
</commit_message>
<xml_diff>
--- a/Updated_Project.pptx
+++ b/Updated_Project.pptx
@@ -3322,1624 +3322,6 @@
       </p:sp>
       <p:sp>
         <p:nvSpPr>
-          <p:cNvPr id="8" name="Rounded Rectangle 7"/>
-          <p:cNvSpPr/>
-          <p:nvPr/>
-        </p:nvSpPr>
-        <p:spPr>
-          <a:xfrm>
-            <a:off x="8641080" y="822960"/>
-            <a:ext cx="2331720" cy="2880360"/>
-          </a:xfrm>
-          <a:prstGeom prst="roundRect">
-            <a:avLst/>
-          </a:prstGeom>
-          <a:solidFill>
-            <a:srgbClr val="FFFFFF"/>
-          </a:solidFill>
-          <a:ln w="12700">
-            <a:solidFill>
-              <a:srgbClr val="E0E0E0"/>
-            </a:solidFill>
-          </a:ln>
-        </p:spPr>
-        <p:style>
-          <a:lnRef idx="1">
-            <a:schemeClr val="accent1"/>
-          </a:lnRef>
-          <a:fillRef idx="3">
-            <a:schemeClr val="accent1"/>
-          </a:fillRef>
-          <a:effectRef idx="2">
-            <a:schemeClr val="accent1"/>
-          </a:effectRef>
-          <a:fontRef idx="minor">
-            <a:schemeClr val="lt1"/>
-          </a:fontRef>
-        </p:style>
-        <p:txBody>
-          <a:bodyPr rtlCol="0" anchor="ctr"/>
-          <a:lstStyle/>
-          <a:p>
-            <a:pPr algn="ctr"/>
-          </a:p>
-        </p:txBody>
-      </p:sp>
-      <p:pic>
-        <p:nvPicPr>
-          <p:cNvPr id="9" name="Picture 8" descr="rishabh_photo_cropped.png"/>
-          <p:cNvPicPr>
-            <a:picLocks noChangeAspect="1"/>
-          </p:cNvPicPr>
-          <p:nvPr/>
-        </p:nvPicPr>
-        <p:blipFill>
-          <a:blip r:embed="rId2"/>
-          <a:stretch>
-            <a:fillRect/>
-          </a:stretch>
-        </p:blipFill>
-        <p:spPr>
-          <a:xfrm>
-            <a:off x="8915400" y="1024128"/>
-            <a:ext cx="1783080" cy="1783080"/>
-          </a:xfrm>
-          <a:prstGeom prst="rect">
-            <a:avLst/>
-          </a:prstGeom>
-        </p:spPr>
-      </p:pic>
-      <p:sp>
-        <p:nvSpPr>
-          <p:cNvPr id="10" name="TextBox 9"/>
-          <p:cNvSpPr txBox="1"/>
-          <p:nvPr/>
-        </p:nvSpPr>
-        <p:spPr>
-          <a:xfrm>
-            <a:off x="8942832" y="2944368"/>
-            <a:ext cx="1737360" cy="237744"/>
-          </a:xfrm>
-          <a:prstGeom prst="rect">
-            <a:avLst/>
-          </a:prstGeom>
-          <a:noFill/>
-        </p:spPr>
-        <p:txBody>
-          <a:bodyPr wrap="square" lIns="36576" rIns="36576" tIns="18288" bIns="18288" anchor="t">
-            <a:spAutoFit/>
-          </a:bodyPr>
-          <a:lstStyle/>
-          <a:p>
-            <a:pPr algn="ctr"/>
-            <a:r>
-              <a:rPr sz="900" b="0">
-                <a:solidFill>
-                  <a:srgbClr val="8D8D8D"/>
-                </a:solidFill>
-                <a:latin typeface="Arial"/>
-              </a:rPr>
-              <a:t>Recent Passport Photo</a:t>
-            </a:r>
-          </a:p>
-        </p:txBody>
-      </p:sp>
-      <p:sp>
-        <p:nvSpPr>
-          <p:cNvPr id="11" name="Rectangle 10"/>
-          <p:cNvSpPr/>
-          <p:nvPr/>
-        </p:nvSpPr>
-        <p:spPr>
-          <a:xfrm>
-            <a:off x="621792" y="3246120"/>
-            <a:ext cx="2240280" cy="384048"/>
-          </a:xfrm>
-          <a:prstGeom prst="rect">
-            <a:avLst/>
-          </a:prstGeom>
-          <a:solidFill>
-            <a:srgbClr val="0F62FE"/>
-          </a:solidFill>
-          <a:ln w="6350">
-            <a:solidFill>
-              <a:srgbClr val="FFFFFF"/>
-            </a:solidFill>
-          </a:ln>
-        </p:spPr>
-        <p:style>
-          <a:lnRef idx="1">
-            <a:schemeClr val="accent1"/>
-          </a:lnRef>
-          <a:fillRef idx="3">
-            <a:schemeClr val="accent1"/>
-          </a:fillRef>
-          <a:effectRef idx="2">
-            <a:schemeClr val="accent1"/>
-          </a:effectRef>
-          <a:fontRef idx="minor">
-            <a:schemeClr val="lt1"/>
-          </a:fontRef>
-        </p:style>
-        <p:txBody>
-          <a:bodyPr rtlCol="0" anchor="ctr"/>
-          <a:lstStyle/>
-          <a:p>
-            <a:pPr algn="ctr"/>
-          </a:p>
-        </p:txBody>
-      </p:sp>
-      <p:sp>
-        <p:nvSpPr>
-          <p:cNvPr id="12" name="TextBox 11"/>
-          <p:cNvSpPr txBox="1"/>
-          <p:nvPr/>
-        </p:nvSpPr>
-        <p:spPr>
-          <a:xfrm>
-            <a:off x="658368" y="3337560"/>
-            <a:ext cx="2167128" cy="164592"/>
-          </a:xfrm>
-          <a:prstGeom prst="rect">
-            <a:avLst/>
-          </a:prstGeom>
-          <a:noFill/>
-        </p:spPr>
-        <p:txBody>
-          <a:bodyPr wrap="square" lIns="36576" rIns="36576" tIns="18288" bIns="18288" anchor="t">
-            <a:spAutoFit/>
-          </a:bodyPr>
-          <a:lstStyle/>
-          <a:p>
-            <a:pPr algn="ctr"/>
-            <a:r>
-              <a:rPr sz="850" b="1">
-                <a:solidFill>
-                  <a:srgbClr val="FFFFFF"/>
-                </a:solidFill>
-                <a:latin typeface="Arial"/>
-              </a:rPr>
-              <a:t>Student Name</a:t>
-            </a:r>
-          </a:p>
-        </p:txBody>
-      </p:sp>
-      <p:sp>
-        <p:nvSpPr>
-          <p:cNvPr id="13" name="Rectangle 12"/>
-          <p:cNvSpPr/>
-          <p:nvPr/>
-        </p:nvSpPr>
-        <p:spPr>
-          <a:xfrm>
-            <a:off x="621792" y="3630168"/>
-            <a:ext cx="2240280" cy="658368"/>
-          </a:xfrm>
-          <a:prstGeom prst="rect">
-            <a:avLst/>
-          </a:prstGeom>
-          <a:solidFill>
-            <a:srgbClr val="F4F4F4"/>
-          </a:solidFill>
-          <a:ln w="6350">
-            <a:solidFill>
-              <a:srgbClr val="FFFFFF"/>
-            </a:solidFill>
-          </a:ln>
-        </p:spPr>
-        <p:style>
-          <a:lnRef idx="1">
-            <a:schemeClr val="accent1"/>
-          </a:lnRef>
-          <a:fillRef idx="3">
-            <a:schemeClr val="accent1"/>
-          </a:fillRef>
-          <a:effectRef idx="2">
-            <a:schemeClr val="accent1"/>
-          </a:effectRef>
-          <a:fontRef idx="minor">
-            <a:schemeClr val="lt1"/>
-          </a:fontRef>
-        </p:style>
-        <p:txBody>
-          <a:bodyPr rtlCol="0" anchor="ctr"/>
-          <a:lstStyle/>
-          <a:p>
-            <a:pPr algn="ctr"/>
-          </a:p>
-        </p:txBody>
-      </p:sp>
-      <p:sp>
-        <p:nvSpPr>
-          <p:cNvPr id="14" name="TextBox 13"/>
-          <p:cNvSpPr txBox="1"/>
-          <p:nvPr/>
-        </p:nvSpPr>
-        <p:spPr>
-          <a:xfrm>
-            <a:off x="676656" y="3758183"/>
-            <a:ext cx="2130552" cy="329184"/>
-          </a:xfrm>
-          <a:prstGeom prst="rect">
-            <a:avLst/>
-          </a:prstGeom>
-          <a:noFill/>
-        </p:spPr>
-        <p:txBody>
-          <a:bodyPr wrap="square" lIns="36576" rIns="36576" tIns="18288" bIns="18288" anchor="ctr">
-            <a:spAutoFit/>
-          </a:bodyPr>
-          <a:lstStyle/>
-          <a:p>
-            <a:pPr algn="ctr"/>
-            <a:r>
-              <a:rPr sz="950" b="0">
-                <a:solidFill>
-                  <a:srgbClr val="161616"/>
-                </a:solidFill>
-                <a:latin typeface="Arial"/>
-              </a:rPr>
-              <a:t>Rishabh Bansal</a:t>
-            </a:r>
-          </a:p>
-        </p:txBody>
-      </p:sp>
-      <p:sp>
-        <p:nvSpPr>
-          <p:cNvPr id="15" name="Rectangle 14"/>
-          <p:cNvSpPr/>
-          <p:nvPr/>
-        </p:nvSpPr>
-        <p:spPr>
-          <a:xfrm>
-            <a:off x="2862072" y="3246120"/>
-            <a:ext cx="2697480" cy="384048"/>
-          </a:xfrm>
-          <a:prstGeom prst="rect">
-            <a:avLst/>
-          </a:prstGeom>
-          <a:solidFill>
-            <a:srgbClr val="0F62FE"/>
-          </a:solidFill>
-          <a:ln w="6350">
-            <a:solidFill>
-              <a:srgbClr val="FFFFFF"/>
-            </a:solidFill>
-          </a:ln>
-        </p:spPr>
-        <p:style>
-          <a:lnRef idx="1">
-            <a:schemeClr val="accent1"/>
-          </a:lnRef>
-          <a:fillRef idx="3">
-            <a:schemeClr val="accent1"/>
-          </a:fillRef>
-          <a:effectRef idx="2">
-            <a:schemeClr val="accent1"/>
-          </a:effectRef>
-          <a:fontRef idx="minor">
-            <a:schemeClr val="lt1"/>
-          </a:fontRef>
-        </p:style>
-        <p:txBody>
-          <a:bodyPr rtlCol="0" anchor="ctr"/>
-          <a:lstStyle/>
-          <a:p>
-            <a:pPr algn="ctr"/>
-          </a:p>
-        </p:txBody>
-      </p:sp>
-      <p:sp>
-        <p:nvSpPr>
-          <p:cNvPr id="16" name="TextBox 15"/>
-          <p:cNvSpPr txBox="1"/>
-          <p:nvPr/>
-        </p:nvSpPr>
-        <p:spPr>
-          <a:xfrm>
-            <a:off x="2898648" y="3337560"/>
-            <a:ext cx="2624328" cy="164592"/>
-          </a:xfrm>
-          <a:prstGeom prst="rect">
-            <a:avLst/>
-          </a:prstGeom>
-          <a:noFill/>
-        </p:spPr>
-        <p:txBody>
-          <a:bodyPr wrap="square" lIns="36576" rIns="36576" tIns="18288" bIns="18288" anchor="t">
-            <a:spAutoFit/>
-          </a:bodyPr>
-          <a:lstStyle/>
-          <a:p>
-            <a:pPr algn="ctr"/>
-            <a:r>
-              <a:rPr sz="850" b="1">
-                <a:solidFill>
-                  <a:srgbClr val="FFFFFF"/>
-                </a:solidFill>
-                <a:latin typeface="Arial"/>
-              </a:rPr>
-              <a:t>College</a:t>
-            </a:r>
-          </a:p>
-        </p:txBody>
-      </p:sp>
-      <p:sp>
-        <p:nvSpPr>
-          <p:cNvPr id="17" name="Rectangle 16"/>
-          <p:cNvSpPr/>
-          <p:nvPr/>
-        </p:nvSpPr>
-        <p:spPr>
-          <a:xfrm>
-            <a:off x="2862072" y="3630168"/>
-            <a:ext cx="2697480" cy="658368"/>
-          </a:xfrm>
-          <a:prstGeom prst="rect">
-            <a:avLst/>
-          </a:prstGeom>
-          <a:solidFill>
-            <a:srgbClr val="F4F4F4"/>
-          </a:solidFill>
-          <a:ln w="6350">
-            <a:solidFill>
-              <a:srgbClr val="FFFFFF"/>
-            </a:solidFill>
-          </a:ln>
-        </p:spPr>
-        <p:style>
-          <a:lnRef idx="1">
-            <a:schemeClr val="accent1"/>
-          </a:lnRef>
-          <a:fillRef idx="3">
-            <a:schemeClr val="accent1"/>
-          </a:fillRef>
-          <a:effectRef idx="2">
-            <a:schemeClr val="accent1"/>
-          </a:effectRef>
-          <a:fontRef idx="minor">
-            <a:schemeClr val="lt1"/>
-          </a:fontRef>
-        </p:style>
-        <p:txBody>
-          <a:bodyPr rtlCol="0" anchor="ctr"/>
-          <a:lstStyle/>
-          <a:p>
-            <a:pPr algn="ctr"/>
-          </a:p>
-        </p:txBody>
-      </p:sp>
-      <p:sp>
-        <p:nvSpPr>
-          <p:cNvPr id="18" name="TextBox 17"/>
-          <p:cNvSpPr txBox="1"/>
-          <p:nvPr/>
-        </p:nvSpPr>
-        <p:spPr>
-          <a:xfrm>
-            <a:off x="2916936" y="3758183"/>
-            <a:ext cx="2587752" cy="329184"/>
-          </a:xfrm>
-          <a:prstGeom prst="rect">
-            <a:avLst/>
-          </a:prstGeom>
-          <a:noFill/>
-        </p:spPr>
-        <p:txBody>
-          <a:bodyPr wrap="square" lIns="36576" rIns="36576" tIns="18288" bIns="18288" anchor="ctr">
-            <a:spAutoFit/>
-          </a:bodyPr>
-          <a:lstStyle/>
-          <a:p>
-            <a:pPr algn="ctr"/>
-            <a:r>
-              <a:rPr sz="950" b="0">
-                <a:solidFill>
-                  <a:srgbClr val="161616"/>
-                </a:solidFill>
-                <a:latin typeface="Arial"/>
-              </a:rPr>
-              <a:t>Maharaja Agrasen Institute of Technology (MAIT)</a:t>
-            </a:r>
-          </a:p>
-        </p:txBody>
-      </p:sp>
-      <p:sp>
-        <p:nvSpPr>
-          <p:cNvPr id="19" name="Rectangle 18"/>
-          <p:cNvSpPr/>
-          <p:nvPr/>
-        </p:nvSpPr>
-        <p:spPr>
-          <a:xfrm>
-            <a:off x="5559552" y="3246120"/>
-            <a:ext cx="2057400" cy="384048"/>
-          </a:xfrm>
-          <a:prstGeom prst="rect">
-            <a:avLst/>
-          </a:prstGeom>
-          <a:solidFill>
-            <a:srgbClr val="0F62FE"/>
-          </a:solidFill>
-          <a:ln w="6350">
-            <a:solidFill>
-              <a:srgbClr val="FFFFFF"/>
-            </a:solidFill>
-          </a:ln>
-        </p:spPr>
-        <p:style>
-          <a:lnRef idx="1">
-            <a:schemeClr val="accent1"/>
-          </a:lnRef>
-          <a:fillRef idx="3">
-            <a:schemeClr val="accent1"/>
-          </a:fillRef>
-          <a:effectRef idx="2">
-            <a:schemeClr val="accent1"/>
-          </a:effectRef>
-          <a:fontRef idx="minor">
-            <a:schemeClr val="lt1"/>
-          </a:fontRef>
-        </p:style>
-        <p:txBody>
-          <a:bodyPr rtlCol="0" anchor="ctr"/>
-          <a:lstStyle/>
-          <a:p>
-            <a:pPr algn="ctr"/>
-          </a:p>
-        </p:txBody>
-      </p:sp>
-      <p:sp>
-        <p:nvSpPr>
-          <p:cNvPr id="20" name="TextBox 19"/>
-          <p:cNvSpPr txBox="1"/>
-          <p:nvPr/>
-        </p:nvSpPr>
-        <p:spPr>
-          <a:xfrm>
-            <a:off x="5596128" y="3337560"/>
-            <a:ext cx="1984248" cy="164592"/>
-          </a:xfrm>
-          <a:prstGeom prst="rect">
-            <a:avLst/>
-          </a:prstGeom>
-          <a:noFill/>
-        </p:spPr>
-        <p:txBody>
-          <a:bodyPr wrap="square" lIns="36576" rIns="36576" tIns="18288" bIns="18288" anchor="t">
-            <a:spAutoFit/>
-          </a:bodyPr>
-          <a:lstStyle/>
-          <a:p>
-            <a:pPr algn="ctr"/>
-            <a:r>
-              <a:rPr sz="850" b="1">
-                <a:solidFill>
-                  <a:srgbClr val="FFFFFF"/>
-                </a:solidFill>
-                <a:latin typeface="Arial"/>
-              </a:rPr>
-              <a:t>Email ID</a:t>
-            </a:r>
-          </a:p>
-        </p:txBody>
-      </p:sp>
-      <p:sp>
-        <p:nvSpPr>
-          <p:cNvPr id="21" name="Rectangle 20"/>
-          <p:cNvSpPr/>
-          <p:nvPr/>
-        </p:nvSpPr>
-        <p:spPr>
-          <a:xfrm>
-            <a:off x="5559552" y="3630168"/>
-            <a:ext cx="2057400" cy="658368"/>
-          </a:xfrm>
-          <a:prstGeom prst="rect">
-            <a:avLst/>
-          </a:prstGeom>
-          <a:solidFill>
-            <a:srgbClr val="F4F4F4"/>
-          </a:solidFill>
-          <a:ln w="6350">
-            <a:solidFill>
-              <a:srgbClr val="FFFFFF"/>
-            </a:solidFill>
-          </a:ln>
-        </p:spPr>
-        <p:style>
-          <a:lnRef idx="1">
-            <a:schemeClr val="accent1"/>
-          </a:lnRef>
-          <a:fillRef idx="3">
-            <a:schemeClr val="accent1"/>
-          </a:fillRef>
-          <a:effectRef idx="2">
-            <a:schemeClr val="accent1"/>
-          </a:effectRef>
-          <a:fontRef idx="minor">
-            <a:schemeClr val="lt1"/>
-          </a:fontRef>
-        </p:style>
-        <p:txBody>
-          <a:bodyPr rtlCol="0" anchor="ctr"/>
-          <a:lstStyle/>
-          <a:p>
-            <a:pPr algn="ctr"/>
-          </a:p>
-        </p:txBody>
-      </p:sp>
-      <p:sp>
-        <p:nvSpPr>
-          <p:cNvPr id="22" name="TextBox 21"/>
-          <p:cNvSpPr txBox="1"/>
-          <p:nvPr/>
-        </p:nvSpPr>
-        <p:spPr>
-          <a:xfrm>
-            <a:off x="5614416" y="3758183"/>
-            <a:ext cx="1947672" cy="329184"/>
-          </a:xfrm>
-          <a:prstGeom prst="rect">
-            <a:avLst/>
-          </a:prstGeom>
-          <a:noFill/>
-        </p:spPr>
-        <p:txBody>
-          <a:bodyPr wrap="square" lIns="36576" rIns="36576" tIns="18288" bIns="18288" anchor="ctr">
-            <a:spAutoFit/>
-          </a:bodyPr>
-          <a:lstStyle/>
-          <a:p>
-            <a:pPr algn="ctr"/>
-            <a:r>
-              <a:rPr sz="950" b="0">
-                <a:solidFill>
-                  <a:srgbClr val="161616"/>
-                </a:solidFill>
-                <a:latin typeface="Arial"/>
-              </a:rPr>
-              <a:t>rishabhb2307@gmail.com</a:t>
-            </a:r>
-          </a:p>
-        </p:txBody>
-      </p:sp>
-      <p:sp>
-        <p:nvSpPr>
-          <p:cNvPr id="23" name="Rectangle 22"/>
-          <p:cNvSpPr/>
-          <p:nvPr/>
-        </p:nvSpPr>
-        <p:spPr>
-          <a:xfrm>
-            <a:off x="7616952" y="3246120"/>
-            <a:ext cx="1874519" cy="384048"/>
-          </a:xfrm>
-          <a:prstGeom prst="rect">
-            <a:avLst/>
-          </a:prstGeom>
-          <a:solidFill>
-            <a:srgbClr val="0F62FE"/>
-          </a:solidFill>
-          <a:ln w="6350">
-            <a:solidFill>
-              <a:srgbClr val="FFFFFF"/>
-            </a:solidFill>
-          </a:ln>
-        </p:spPr>
-        <p:style>
-          <a:lnRef idx="1">
-            <a:schemeClr val="accent1"/>
-          </a:lnRef>
-          <a:fillRef idx="3">
-            <a:schemeClr val="accent1"/>
-          </a:fillRef>
-          <a:effectRef idx="2">
-            <a:schemeClr val="accent1"/>
-          </a:effectRef>
-          <a:fontRef idx="minor">
-            <a:schemeClr val="lt1"/>
-          </a:fontRef>
-        </p:style>
-        <p:txBody>
-          <a:bodyPr rtlCol="0" anchor="ctr"/>
-          <a:lstStyle/>
-          <a:p>
-            <a:pPr algn="ctr"/>
-          </a:p>
-        </p:txBody>
-      </p:sp>
-      <p:sp>
-        <p:nvSpPr>
-          <p:cNvPr id="24" name="TextBox 23"/>
-          <p:cNvSpPr txBox="1"/>
-          <p:nvPr/>
-        </p:nvSpPr>
-        <p:spPr>
-          <a:xfrm>
-            <a:off x="7653527" y="3337560"/>
-            <a:ext cx="1801367" cy="164592"/>
-          </a:xfrm>
-          <a:prstGeom prst="rect">
-            <a:avLst/>
-          </a:prstGeom>
-          <a:noFill/>
-        </p:spPr>
-        <p:txBody>
-          <a:bodyPr wrap="square" lIns="36576" rIns="36576" tIns="18288" bIns="18288" anchor="t">
-            <a:spAutoFit/>
-          </a:bodyPr>
-          <a:lstStyle/>
-          <a:p>
-            <a:pPr algn="ctr"/>
-            <a:r>
-              <a:rPr sz="850" b="1">
-                <a:solidFill>
-                  <a:srgbClr val="FFFFFF"/>
-                </a:solidFill>
-                <a:latin typeface="Arial"/>
-              </a:rPr>
-              <a:t>Mobile [WhatsApp]</a:t>
-            </a:r>
-          </a:p>
-        </p:txBody>
-      </p:sp>
-      <p:sp>
-        <p:nvSpPr>
-          <p:cNvPr id="25" name="Rectangle 24"/>
-          <p:cNvSpPr/>
-          <p:nvPr/>
-        </p:nvSpPr>
-        <p:spPr>
-          <a:xfrm>
-            <a:off x="7616952" y="3630168"/>
-            <a:ext cx="1874519" cy="658368"/>
-          </a:xfrm>
-          <a:prstGeom prst="rect">
-            <a:avLst/>
-          </a:prstGeom>
-          <a:solidFill>
-            <a:srgbClr val="F4F4F4"/>
-          </a:solidFill>
-          <a:ln w="6350">
-            <a:solidFill>
-              <a:srgbClr val="FFFFFF"/>
-            </a:solidFill>
-          </a:ln>
-        </p:spPr>
-        <p:style>
-          <a:lnRef idx="1">
-            <a:schemeClr val="accent1"/>
-          </a:lnRef>
-          <a:fillRef idx="3">
-            <a:schemeClr val="accent1"/>
-          </a:fillRef>
-          <a:effectRef idx="2">
-            <a:schemeClr val="accent1"/>
-          </a:effectRef>
-          <a:fontRef idx="minor">
-            <a:schemeClr val="lt1"/>
-          </a:fontRef>
-        </p:style>
-        <p:txBody>
-          <a:bodyPr rtlCol="0" anchor="ctr"/>
-          <a:lstStyle/>
-          <a:p>
-            <a:pPr algn="ctr"/>
-          </a:p>
-        </p:txBody>
-      </p:sp>
-      <p:sp>
-        <p:nvSpPr>
-          <p:cNvPr id="26" name="TextBox 25"/>
-          <p:cNvSpPr txBox="1"/>
-          <p:nvPr/>
-        </p:nvSpPr>
-        <p:spPr>
-          <a:xfrm>
-            <a:off x="7671816" y="3758183"/>
-            <a:ext cx="1764791" cy="329184"/>
-          </a:xfrm>
-          <a:prstGeom prst="rect">
-            <a:avLst/>
-          </a:prstGeom>
-          <a:noFill/>
-        </p:spPr>
-        <p:txBody>
-          <a:bodyPr wrap="square" lIns="36576" rIns="36576" tIns="18288" bIns="18288" anchor="ctr">
-            <a:spAutoFit/>
-          </a:bodyPr>
-          <a:lstStyle/>
-          <a:p>
-            <a:pPr algn="ctr"/>
-            <a:r>
-              <a:rPr sz="950" b="0">
-                <a:solidFill>
-                  <a:srgbClr val="161616"/>
-                </a:solidFill>
-                <a:latin typeface="Arial"/>
-              </a:rPr>
-              <a:t>8595803248</a:t>
-            </a:r>
-          </a:p>
-        </p:txBody>
-      </p:sp>
-      <p:sp>
-        <p:nvSpPr>
-          <p:cNvPr id="27" name="Rectangle 26"/>
-          <p:cNvSpPr/>
-          <p:nvPr/>
-        </p:nvSpPr>
-        <p:spPr>
-          <a:xfrm>
-            <a:off x="9491472" y="3246120"/>
-            <a:ext cx="2651760" cy="384048"/>
-          </a:xfrm>
-          <a:prstGeom prst="rect">
-            <a:avLst/>
-          </a:prstGeom>
-          <a:solidFill>
-            <a:srgbClr val="0F62FE"/>
-          </a:solidFill>
-          <a:ln w="6350">
-            <a:solidFill>
-              <a:srgbClr val="FFFFFF"/>
-            </a:solidFill>
-          </a:ln>
-        </p:spPr>
-        <p:style>
-          <a:lnRef idx="1">
-            <a:schemeClr val="accent1"/>
-          </a:lnRef>
-          <a:fillRef idx="3">
-            <a:schemeClr val="accent1"/>
-          </a:fillRef>
-          <a:effectRef idx="2">
-            <a:schemeClr val="accent1"/>
-          </a:effectRef>
-          <a:fontRef idx="minor">
-            <a:schemeClr val="lt1"/>
-          </a:fontRef>
-        </p:style>
-        <p:txBody>
-          <a:bodyPr rtlCol="0" anchor="ctr"/>
-          <a:lstStyle/>
-          <a:p>
-            <a:pPr algn="ctr"/>
-          </a:p>
-        </p:txBody>
-      </p:sp>
-      <p:sp>
-        <p:nvSpPr>
-          <p:cNvPr id="28" name="TextBox 27"/>
-          <p:cNvSpPr txBox="1"/>
-          <p:nvPr/>
-        </p:nvSpPr>
-        <p:spPr>
-          <a:xfrm>
-            <a:off x="9528047" y="3337560"/>
-            <a:ext cx="2578608" cy="164592"/>
-          </a:xfrm>
-          <a:prstGeom prst="rect">
-            <a:avLst/>
-          </a:prstGeom>
-          <a:noFill/>
-        </p:spPr>
-        <p:txBody>
-          <a:bodyPr wrap="square" lIns="36576" rIns="36576" tIns="18288" bIns="18288" anchor="t">
-            <a:spAutoFit/>
-          </a:bodyPr>
-          <a:lstStyle/>
-          <a:p>
-            <a:pPr algn="ctr"/>
-            <a:r>
-              <a:rPr sz="850" b="1">
-                <a:solidFill>
-                  <a:srgbClr val="FFFFFF"/>
-                </a:solidFill>
-                <a:latin typeface="Arial"/>
-              </a:rPr>
-              <a:t>Domain</a:t>
-            </a:r>
-          </a:p>
-        </p:txBody>
-      </p:sp>
-      <p:sp>
-        <p:nvSpPr>
-          <p:cNvPr id="29" name="Rectangle 28"/>
-          <p:cNvSpPr/>
-          <p:nvPr/>
-        </p:nvSpPr>
-        <p:spPr>
-          <a:xfrm>
-            <a:off x="9491472" y="3630168"/>
-            <a:ext cx="2651760" cy="658368"/>
-          </a:xfrm>
-          <a:prstGeom prst="rect">
-            <a:avLst/>
-          </a:prstGeom>
-          <a:solidFill>
-            <a:srgbClr val="F4F4F4"/>
-          </a:solidFill>
-          <a:ln w="6350">
-            <a:solidFill>
-              <a:srgbClr val="FFFFFF"/>
-            </a:solidFill>
-          </a:ln>
-        </p:spPr>
-        <p:style>
-          <a:lnRef idx="1">
-            <a:schemeClr val="accent1"/>
-          </a:lnRef>
-          <a:fillRef idx="3">
-            <a:schemeClr val="accent1"/>
-          </a:fillRef>
-          <a:effectRef idx="2">
-            <a:schemeClr val="accent1"/>
-          </a:effectRef>
-          <a:fontRef idx="minor">
-            <a:schemeClr val="lt1"/>
-          </a:fontRef>
-        </p:style>
-        <p:txBody>
-          <a:bodyPr rtlCol="0" anchor="ctr"/>
-          <a:lstStyle/>
-          <a:p>
-            <a:pPr algn="ctr"/>
-          </a:p>
-        </p:txBody>
-      </p:sp>
-      <p:sp>
-        <p:nvSpPr>
-          <p:cNvPr id="30" name="TextBox 29"/>
-          <p:cNvSpPr txBox="1"/>
-          <p:nvPr/>
-        </p:nvSpPr>
-        <p:spPr>
-          <a:xfrm>
-            <a:off x="9546336" y="3758183"/>
-            <a:ext cx="2542032" cy="329184"/>
-          </a:xfrm>
-          <a:prstGeom prst="rect">
-            <a:avLst/>
-          </a:prstGeom>
-          <a:noFill/>
-        </p:spPr>
-        <p:txBody>
-          <a:bodyPr wrap="square" lIns="36576" rIns="36576" tIns="18288" bIns="18288" anchor="ctr">
-            <a:spAutoFit/>
-          </a:bodyPr>
-          <a:lstStyle/>
-          <a:p>
-            <a:pPr algn="ctr"/>
-            <a:r>
-              <a:rPr sz="950" b="0">
-                <a:solidFill>
-                  <a:srgbClr val="161616"/>
-                </a:solidFill>
-                <a:latin typeface="Arial"/>
-              </a:rPr>
-              <a:t>Artificial Intelligence / Sustainability</a:t>
-            </a:r>
-          </a:p>
-        </p:txBody>
-      </p:sp>
-      <p:sp>
-        <p:nvSpPr>
-          <p:cNvPr id="31" name="Rounded Rectangle 30"/>
-          <p:cNvSpPr/>
-          <p:nvPr/>
-        </p:nvSpPr>
-        <p:spPr>
-          <a:xfrm>
-            <a:off x="621792" y="4800600"/>
-            <a:ext cx="2743200" cy="960120"/>
-          </a:xfrm>
-          <a:prstGeom prst="roundRect">
-            <a:avLst/>
-          </a:prstGeom>
-          <a:solidFill>
-            <a:srgbClr val="FFFFFF"/>
-          </a:solidFill>
-          <a:ln w="12700">
-            <a:solidFill>
-              <a:srgbClr val="E0E0E0"/>
-            </a:solidFill>
-          </a:ln>
-        </p:spPr>
-        <p:style>
-          <a:lnRef idx="1">
-            <a:schemeClr val="accent1"/>
-          </a:lnRef>
-          <a:fillRef idx="3">
-            <a:schemeClr val="accent1"/>
-          </a:fillRef>
-          <a:effectRef idx="2">
-            <a:schemeClr val="accent1"/>
-          </a:effectRef>
-          <a:fontRef idx="minor">
-            <a:schemeClr val="lt1"/>
-          </a:fontRef>
-        </p:style>
-        <p:txBody>
-          <a:bodyPr rtlCol="0" anchor="ctr"/>
-          <a:lstStyle/>
-          <a:p>
-            <a:pPr algn="ctr"/>
-          </a:p>
-        </p:txBody>
-      </p:sp>
-      <p:sp>
-        <p:nvSpPr>
-          <p:cNvPr id="32" name="Rectangle 31"/>
-          <p:cNvSpPr/>
-          <p:nvPr/>
-        </p:nvSpPr>
-        <p:spPr>
-          <a:xfrm>
-            <a:off x="621792" y="4800600"/>
-            <a:ext cx="54864" cy="960120"/>
-          </a:xfrm>
-          <a:prstGeom prst="rect">
-            <a:avLst/>
-          </a:prstGeom>
-          <a:solidFill>
-            <a:srgbClr val="0F62FE"/>
-          </a:solidFill>
-          <a:ln>
-            <a:noFill/>
-          </a:ln>
-        </p:spPr>
-        <p:style>
-          <a:lnRef idx="1">
-            <a:schemeClr val="accent1"/>
-          </a:lnRef>
-          <a:fillRef idx="3">
-            <a:schemeClr val="accent1"/>
-          </a:fillRef>
-          <a:effectRef idx="2">
-            <a:schemeClr val="accent1"/>
-          </a:effectRef>
-          <a:fontRef idx="minor">
-            <a:schemeClr val="lt1"/>
-          </a:fontRef>
-        </p:style>
-        <p:txBody>
-          <a:bodyPr rtlCol="0" anchor="ctr"/>
-          <a:lstStyle/>
-          <a:p>
-            <a:pPr algn="ctr"/>
-          </a:p>
-        </p:txBody>
-      </p:sp>
-      <p:sp>
-        <p:nvSpPr>
-          <p:cNvPr id="33" name="Oval 32"/>
-          <p:cNvSpPr/>
-          <p:nvPr/>
-        </p:nvSpPr>
-        <p:spPr>
-          <a:xfrm>
-            <a:off x="786384" y="4965192"/>
-            <a:ext cx="384048" cy="384048"/>
-          </a:xfrm>
-          <a:prstGeom prst="ellipse">
-            <a:avLst/>
-          </a:prstGeom>
-          <a:solidFill>
-            <a:srgbClr val="EDF2FF"/>
-          </a:solidFill>
-          <a:ln w="12700">
-            <a:solidFill>
-              <a:srgbClr val="0F62FE"/>
-            </a:solidFill>
-          </a:ln>
-        </p:spPr>
-        <p:style>
-          <a:lnRef idx="1">
-            <a:schemeClr val="accent1"/>
-          </a:lnRef>
-          <a:fillRef idx="3">
-            <a:schemeClr val="accent1"/>
-          </a:fillRef>
-          <a:effectRef idx="2">
-            <a:schemeClr val="accent1"/>
-          </a:effectRef>
-          <a:fontRef idx="minor">
-            <a:schemeClr val="lt1"/>
-          </a:fontRef>
-        </p:style>
-        <p:txBody>
-          <a:bodyPr rtlCol="0" anchor="ctr"/>
-          <a:lstStyle/>
-          <a:p>
-            <a:pPr algn="ctr"/>
-          </a:p>
-        </p:txBody>
-      </p:sp>
-      <p:sp>
-        <p:nvSpPr>
-          <p:cNvPr id="34" name="TextBox 33"/>
-          <p:cNvSpPr txBox="1"/>
-          <p:nvPr/>
-        </p:nvSpPr>
-        <p:spPr>
-          <a:xfrm>
-            <a:off x="786384" y="5001768"/>
-            <a:ext cx="384048" cy="228600"/>
-          </a:xfrm>
-          <a:prstGeom prst="rect">
-            <a:avLst/>
-          </a:prstGeom>
-          <a:noFill/>
-        </p:spPr>
-        <p:txBody>
-          <a:bodyPr wrap="square" lIns="36576" rIns="36576" tIns="18288" bIns="18288" anchor="t">
-            <a:spAutoFit/>
-          </a:bodyPr>
-          <a:lstStyle/>
-          <a:p>
-            <a:pPr algn="ctr"/>
-            <a:r>
-              <a:rPr sz="1200" b="1">
-                <a:solidFill>
-                  <a:srgbClr val="0F62FE"/>
-                </a:solidFill>
-                <a:latin typeface="Arial"/>
-              </a:rPr>
-              <a:t>1</a:t>
-            </a:r>
-          </a:p>
-        </p:txBody>
-      </p:sp>
-      <p:sp>
-        <p:nvSpPr>
-          <p:cNvPr id="35" name="TextBox 34"/>
-          <p:cNvSpPr txBox="1"/>
-          <p:nvPr/>
-        </p:nvSpPr>
-        <p:spPr>
-          <a:xfrm>
-            <a:off x="1280160" y="4937760"/>
-            <a:ext cx="1947672" cy="320040"/>
-          </a:xfrm>
-          <a:prstGeom prst="rect">
-            <a:avLst/>
-          </a:prstGeom>
-          <a:noFill/>
-        </p:spPr>
-        <p:txBody>
-          <a:bodyPr wrap="square" lIns="36576" rIns="36576" tIns="18288" bIns="18288" anchor="t">
-            <a:spAutoFit/>
-          </a:bodyPr>
-          <a:lstStyle/>
-          <a:p>
-            <a:pPr algn="l"/>
-            <a:r>
-              <a:rPr sz="1350" b="1">
-                <a:solidFill>
-                  <a:srgbClr val="161616"/>
-                </a:solidFill>
-                <a:latin typeface="Arial"/>
-              </a:rPr>
-              <a:t>Mandatory Stack</a:t>
-            </a:r>
-          </a:p>
-        </p:txBody>
-      </p:sp>
-      <p:sp>
-        <p:nvSpPr>
-          <p:cNvPr id="36" name="TextBox 35"/>
-          <p:cNvSpPr txBox="1"/>
-          <p:nvPr/>
-        </p:nvSpPr>
-        <p:spPr>
-          <a:xfrm>
-            <a:off x="822960" y="5312664"/>
-            <a:ext cx="2359152" cy="393192"/>
-          </a:xfrm>
-          <a:prstGeom prst="rect">
-            <a:avLst/>
-          </a:prstGeom>
-          <a:noFill/>
-        </p:spPr>
-        <p:txBody>
-          <a:bodyPr wrap="square" lIns="36576" rIns="36576" tIns="18288" bIns="18288" anchor="t">
-            <a:spAutoFit/>
-          </a:bodyPr>
-          <a:lstStyle/>
-          <a:p>
-            <a:pPr algn="l"/>
-            <a:r>
-              <a:rPr sz="1050" b="0">
-                <a:solidFill>
-                  <a:srgbClr val="393939"/>
-                </a:solidFill>
-                <a:latin typeface="Arial"/>
-              </a:rPr>
-              <a:t>IBM Cloud Lite • IBM Granite • RAG</a:t>
-            </a:r>
-          </a:p>
-        </p:txBody>
-      </p:sp>
-      <p:sp>
-        <p:nvSpPr>
-          <p:cNvPr id="37" name="Rounded Rectangle 36"/>
-          <p:cNvSpPr/>
-          <p:nvPr/>
-        </p:nvSpPr>
-        <p:spPr>
-          <a:xfrm>
-            <a:off x="3611880" y="4800600"/>
-            <a:ext cx="2743200" cy="960120"/>
-          </a:xfrm>
-          <a:prstGeom prst="roundRect">
-            <a:avLst/>
-          </a:prstGeom>
-          <a:solidFill>
-            <a:srgbClr val="FFFFFF"/>
-          </a:solidFill>
-          <a:ln w="12700">
-            <a:solidFill>
-              <a:srgbClr val="E0E0E0"/>
-            </a:solidFill>
-          </a:ln>
-        </p:spPr>
-        <p:style>
-          <a:lnRef idx="1">
-            <a:schemeClr val="accent1"/>
-          </a:lnRef>
-          <a:fillRef idx="3">
-            <a:schemeClr val="accent1"/>
-          </a:fillRef>
-          <a:effectRef idx="2">
-            <a:schemeClr val="accent1"/>
-          </a:effectRef>
-          <a:fontRef idx="minor">
-            <a:schemeClr val="lt1"/>
-          </a:fontRef>
-        </p:style>
-        <p:txBody>
-          <a:bodyPr rtlCol="0" anchor="ctr"/>
-          <a:lstStyle/>
-          <a:p>
-            <a:pPr algn="ctr"/>
-          </a:p>
-        </p:txBody>
-      </p:sp>
-      <p:sp>
-        <p:nvSpPr>
-          <p:cNvPr id="38" name="Rectangle 37"/>
-          <p:cNvSpPr/>
-          <p:nvPr/>
-        </p:nvSpPr>
-        <p:spPr>
-          <a:xfrm>
-            <a:off x="3611880" y="4800600"/>
-            <a:ext cx="54864" cy="960120"/>
-          </a:xfrm>
-          <a:prstGeom prst="rect">
-            <a:avLst/>
-          </a:prstGeom>
-          <a:solidFill>
-            <a:srgbClr val="24A148"/>
-          </a:solidFill>
-          <a:ln>
-            <a:noFill/>
-          </a:ln>
-        </p:spPr>
-        <p:style>
-          <a:lnRef idx="1">
-            <a:schemeClr val="accent1"/>
-          </a:lnRef>
-          <a:fillRef idx="3">
-            <a:schemeClr val="accent1"/>
-          </a:fillRef>
-          <a:effectRef idx="2">
-            <a:schemeClr val="accent1"/>
-          </a:effectRef>
-          <a:fontRef idx="minor">
-            <a:schemeClr val="lt1"/>
-          </a:fontRef>
-        </p:style>
-        <p:txBody>
-          <a:bodyPr rtlCol="0" anchor="ctr"/>
-          <a:lstStyle/>
-          <a:p>
-            <a:pPr algn="ctr"/>
-          </a:p>
-        </p:txBody>
-      </p:sp>
-      <p:sp>
-        <p:nvSpPr>
-          <p:cNvPr id="39" name="Oval 38"/>
-          <p:cNvSpPr/>
-          <p:nvPr/>
-        </p:nvSpPr>
-        <p:spPr>
-          <a:xfrm>
-            <a:off x="3776472" y="4965192"/>
-            <a:ext cx="384048" cy="384048"/>
-          </a:xfrm>
-          <a:prstGeom prst="ellipse">
-            <a:avLst/>
-          </a:prstGeom>
-          <a:solidFill>
-            <a:srgbClr val="EDF2FF"/>
-          </a:solidFill>
-          <a:ln w="12700">
-            <a:solidFill>
-              <a:srgbClr val="24A148"/>
-            </a:solidFill>
-          </a:ln>
-        </p:spPr>
-        <p:style>
-          <a:lnRef idx="1">
-            <a:schemeClr val="accent1"/>
-          </a:lnRef>
-          <a:fillRef idx="3">
-            <a:schemeClr val="accent1"/>
-          </a:fillRef>
-          <a:effectRef idx="2">
-            <a:schemeClr val="accent1"/>
-          </a:effectRef>
-          <a:fontRef idx="minor">
-            <a:schemeClr val="lt1"/>
-          </a:fontRef>
-        </p:style>
-        <p:txBody>
-          <a:bodyPr rtlCol="0" anchor="ctr"/>
-          <a:lstStyle/>
-          <a:p>
-            <a:pPr algn="ctr"/>
-          </a:p>
-        </p:txBody>
-      </p:sp>
-      <p:sp>
-        <p:nvSpPr>
-          <p:cNvPr id="40" name="TextBox 39"/>
-          <p:cNvSpPr txBox="1"/>
-          <p:nvPr/>
-        </p:nvSpPr>
-        <p:spPr>
-          <a:xfrm>
-            <a:off x="3776472" y="5001768"/>
-            <a:ext cx="384048" cy="228600"/>
-          </a:xfrm>
-          <a:prstGeom prst="rect">
-            <a:avLst/>
-          </a:prstGeom>
-          <a:noFill/>
-        </p:spPr>
-        <p:txBody>
-          <a:bodyPr wrap="square" lIns="36576" rIns="36576" tIns="18288" bIns="18288" anchor="t">
-            <a:spAutoFit/>
-          </a:bodyPr>
-          <a:lstStyle/>
-          <a:p>
-            <a:pPr algn="ctr"/>
-            <a:r>
-              <a:rPr sz="1200" b="1">
-                <a:solidFill>
-                  <a:srgbClr val="24A148"/>
-                </a:solidFill>
-                <a:latin typeface="Arial"/>
-              </a:rPr>
-              <a:t>2</a:t>
-            </a:r>
-          </a:p>
-        </p:txBody>
-      </p:sp>
-      <p:sp>
-        <p:nvSpPr>
-          <p:cNvPr id="41" name="TextBox 40"/>
-          <p:cNvSpPr txBox="1"/>
-          <p:nvPr/>
-        </p:nvSpPr>
-        <p:spPr>
-          <a:xfrm>
-            <a:off x="4270248" y="4937760"/>
-            <a:ext cx="1947672" cy="320040"/>
-          </a:xfrm>
-          <a:prstGeom prst="rect">
-            <a:avLst/>
-          </a:prstGeom>
-          <a:noFill/>
-        </p:spPr>
-        <p:txBody>
-          <a:bodyPr wrap="square" lIns="36576" rIns="36576" tIns="18288" bIns="18288" anchor="t">
-            <a:spAutoFit/>
-          </a:bodyPr>
-          <a:lstStyle/>
-          <a:p>
-            <a:pPr algn="l"/>
-            <a:r>
-              <a:rPr sz="1350" b="1">
-                <a:solidFill>
-                  <a:srgbClr val="161616"/>
-                </a:solidFill>
-                <a:latin typeface="Arial"/>
-              </a:rPr>
-              <a:t>Submission Focus</a:t>
-            </a:r>
-          </a:p>
-        </p:txBody>
-      </p:sp>
-      <p:sp>
-        <p:nvSpPr>
-          <p:cNvPr id="42" name="TextBox 41"/>
-          <p:cNvSpPr txBox="1"/>
-          <p:nvPr/>
-        </p:nvSpPr>
-        <p:spPr>
-          <a:xfrm>
-            <a:off x="3813048" y="5312664"/>
-            <a:ext cx="2359152" cy="393192"/>
-          </a:xfrm>
-          <a:prstGeom prst="rect">
-            <a:avLst/>
-          </a:prstGeom>
-          <a:noFill/>
-        </p:spPr>
-        <p:txBody>
-          <a:bodyPr wrap="square" lIns="36576" rIns="36576" tIns="18288" bIns="18288" anchor="t">
-            <a:spAutoFit/>
-          </a:bodyPr>
-          <a:lstStyle/>
-          <a:p>
-            <a:pPr algn="l"/>
-            <a:r>
-              <a:rPr sz="1050" b="0">
-                <a:solidFill>
-                  <a:srgbClr val="393939"/>
-                </a:solidFill>
-                <a:latin typeface="Arial"/>
-              </a:rPr>
-              <a:t>Agentic AI for sustainable living</a:t>
-            </a:r>
-          </a:p>
-        </p:txBody>
-      </p:sp>
-      <p:sp>
-        <p:nvSpPr>
-          <p:cNvPr id="43" name="Rounded Rectangle 42"/>
-          <p:cNvSpPr/>
-          <p:nvPr/>
-        </p:nvSpPr>
-        <p:spPr>
-          <a:xfrm>
-            <a:off x="6601968" y="4800600"/>
-            <a:ext cx="2743200" cy="960120"/>
-          </a:xfrm>
-          <a:prstGeom prst="roundRect">
-            <a:avLst/>
-          </a:prstGeom>
-          <a:solidFill>
-            <a:srgbClr val="FFFFFF"/>
-          </a:solidFill>
-          <a:ln w="12700">
-            <a:solidFill>
-              <a:srgbClr val="E0E0E0"/>
-            </a:solidFill>
-          </a:ln>
-        </p:spPr>
-        <p:style>
-          <a:lnRef idx="1">
-            <a:schemeClr val="accent1"/>
-          </a:lnRef>
-          <a:fillRef idx="3">
-            <a:schemeClr val="accent1"/>
-          </a:fillRef>
-          <a:effectRef idx="2">
-            <a:schemeClr val="accent1"/>
-          </a:effectRef>
-          <a:fontRef idx="minor">
-            <a:schemeClr val="lt1"/>
-          </a:fontRef>
-        </p:style>
-        <p:txBody>
-          <a:bodyPr rtlCol="0" anchor="ctr"/>
-          <a:lstStyle/>
-          <a:p>
-            <a:pPr algn="ctr"/>
-          </a:p>
-        </p:txBody>
-      </p:sp>
-      <p:sp>
-        <p:nvSpPr>
-          <p:cNvPr id="44" name="Rectangle 43"/>
-          <p:cNvSpPr/>
-          <p:nvPr/>
-        </p:nvSpPr>
-        <p:spPr>
-          <a:xfrm>
-            <a:off x="6601968" y="4800600"/>
-            <a:ext cx="54864" cy="960120"/>
-          </a:xfrm>
-          <a:prstGeom prst="rect">
-            <a:avLst/>
-          </a:prstGeom>
-          <a:solidFill>
-            <a:srgbClr val="007D79"/>
-          </a:solidFill>
-          <a:ln>
-            <a:noFill/>
-          </a:ln>
-        </p:spPr>
-        <p:style>
-          <a:lnRef idx="1">
-            <a:schemeClr val="accent1"/>
-          </a:lnRef>
-          <a:fillRef idx="3">
-            <a:schemeClr val="accent1"/>
-          </a:fillRef>
-          <a:effectRef idx="2">
-            <a:schemeClr val="accent1"/>
-          </a:effectRef>
-          <a:fontRef idx="minor">
-            <a:schemeClr val="lt1"/>
-          </a:fontRef>
-        </p:style>
-        <p:txBody>
-          <a:bodyPr rtlCol="0" anchor="ctr"/>
-          <a:lstStyle/>
-          <a:p>
-            <a:pPr algn="ctr"/>
-          </a:p>
-        </p:txBody>
-      </p:sp>
-      <p:sp>
-        <p:nvSpPr>
-          <p:cNvPr id="45" name="Oval 44"/>
-          <p:cNvSpPr/>
-          <p:nvPr/>
-        </p:nvSpPr>
-        <p:spPr>
-          <a:xfrm>
-            <a:off x="6766559" y="4965192"/>
-            <a:ext cx="384048" cy="384048"/>
-          </a:xfrm>
-          <a:prstGeom prst="ellipse">
-            <a:avLst/>
-          </a:prstGeom>
-          <a:solidFill>
-            <a:srgbClr val="EDF2FF"/>
-          </a:solidFill>
-          <a:ln w="12700">
-            <a:solidFill>
-              <a:srgbClr val="007D79"/>
-            </a:solidFill>
-          </a:ln>
-        </p:spPr>
-        <p:style>
-          <a:lnRef idx="1">
-            <a:schemeClr val="accent1"/>
-          </a:lnRef>
-          <a:fillRef idx="3">
-            <a:schemeClr val="accent1"/>
-          </a:fillRef>
-          <a:effectRef idx="2">
-            <a:schemeClr val="accent1"/>
-          </a:effectRef>
-          <a:fontRef idx="minor">
-            <a:schemeClr val="lt1"/>
-          </a:fontRef>
-        </p:style>
-        <p:txBody>
-          <a:bodyPr rtlCol="0" anchor="ctr"/>
-          <a:lstStyle/>
-          <a:p>
-            <a:pPr algn="ctr"/>
-          </a:p>
-        </p:txBody>
-      </p:sp>
-      <p:sp>
-        <p:nvSpPr>
-          <p:cNvPr id="46" name="TextBox 45"/>
-          <p:cNvSpPr txBox="1"/>
-          <p:nvPr/>
-        </p:nvSpPr>
-        <p:spPr>
-          <a:xfrm>
-            <a:off x="6766559" y="5001768"/>
-            <a:ext cx="384048" cy="228600"/>
-          </a:xfrm>
-          <a:prstGeom prst="rect">
-            <a:avLst/>
-          </a:prstGeom>
-          <a:noFill/>
-        </p:spPr>
-        <p:txBody>
-          <a:bodyPr wrap="square" lIns="36576" rIns="36576" tIns="18288" bIns="18288" anchor="t">
-            <a:spAutoFit/>
-          </a:bodyPr>
-          <a:lstStyle/>
-          <a:p>
-            <a:pPr algn="ctr"/>
-            <a:r>
-              <a:rPr sz="1200" b="1">
-                <a:solidFill>
-                  <a:srgbClr val="007D79"/>
-                </a:solidFill>
-                <a:latin typeface="Arial"/>
-              </a:rPr>
-              <a:t>3</a:t>
-            </a:r>
-          </a:p>
-        </p:txBody>
-      </p:sp>
-      <p:sp>
-        <p:nvSpPr>
-          <p:cNvPr id="47" name="TextBox 46"/>
-          <p:cNvSpPr txBox="1"/>
-          <p:nvPr/>
-        </p:nvSpPr>
-        <p:spPr>
-          <a:xfrm>
-            <a:off x="7260336" y="4937760"/>
-            <a:ext cx="1947672" cy="320040"/>
-          </a:xfrm>
-          <a:prstGeom prst="rect">
-            <a:avLst/>
-          </a:prstGeom>
-          <a:noFill/>
-        </p:spPr>
-        <p:txBody>
-          <a:bodyPr wrap="square" lIns="36576" rIns="36576" tIns="18288" bIns="18288" anchor="t">
-            <a:spAutoFit/>
-          </a:bodyPr>
-          <a:lstStyle/>
-          <a:p>
-            <a:pPr algn="l"/>
-            <a:r>
-              <a:rPr sz="1350" b="1">
-                <a:solidFill>
-                  <a:srgbClr val="161616"/>
-                </a:solidFill>
-                <a:latin typeface="Arial"/>
-              </a:rPr>
-              <a:t>Project Outcome</a:t>
-            </a:r>
-          </a:p>
-        </p:txBody>
-      </p:sp>
-      <p:sp>
-        <p:nvSpPr>
-          <p:cNvPr id="48" name="TextBox 47"/>
-          <p:cNvSpPr txBox="1"/>
-          <p:nvPr/>
-        </p:nvSpPr>
-        <p:spPr>
-          <a:xfrm>
-            <a:off x="6803136" y="5312664"/>
-            <a:ext cx="2359152" cy="393192"/>
-          </a:xfrm>
-          <a:prstGeom prst="rect">
-            <a:avLst/>
-          </a:prstGeom>
-          <a:noFill/>
-        </p:spPr>
-        <p:txBody>
-          <a:bodyPr wrap="square" lIns="36576" rIns="36576" tIns="18288" bIns="18288" anchor="t">
-            <a:spAutoFit/>
-          </a:bodyPr>
-          <a:lstStyle/>
-          <a:p>
-            <a:pPr algn="l"/>
-            <a:r>
-              <a:rPr sz="1050" b="0">
-                <a:solidFill>
-                  <a:srgbClr val="393939"/>
-                </a:solidFill>
-                <a:latin typeface="Arial"/>
-              </a:rPr>
-              <a:t>Personalized eco guidance assistant</a:t>
-            </a:r>
-          </a:p>
-        </p:txBody>
-      </p:sp>
-      <p:sp>
-        <p:nvSpPr>
           <p:cNvPr id="49" name="TextBox 48"/>
           <p:cNvSpPr txBox="1"/>
           <p:nvPr/>
@@ -6347,7 +4729,7 @@
           </a:bodyPr>
           <a:lstStyle/>
           <a:p>
-            <a:pPr>
+            <a:pPr marL="228600" indent="-228600">
               <a:lnSpc>
                 <a:spcPct val="100000"/>
               </a:lnSpc>
@@ -6366,7 +4748,7 @@
             </a:r>
           </a:p>
           <a:p>
-            <a:pPr>
+            <a:pPr marL="228600" indent="-228600">
               <a:lnSpc>
                 <a:spcPct val="100000"/>
               </a:lnSpc>
@@ -6385,7 +4767,7 @@
             </a:r>
           </a:p>
           <a:p>
-            <a:pPr>
+            <a:pPr marL="228600" indent="-228600">
               <a:lnSpc>
                 <a:spcPct val="100000"/>
               </a:lnSpc>
@@ -6404,7 +4786,7 @@
             </a:r>
           </a:p>
           <a:p>
-            <a:pPr>
+            <a:pPr marL="228600" indent="-228600">
               <a:lnSpc>
                 <a:spcPct val="100000"/>
               </a:lnSpc>
@@ -12814,6 +11196,7 @@
           </a:bodyPr>
           <a:lstStyle/>
           <a:p>
+            <a:pPr marL="228600" indent="-228600"/>
             <a:r>
               <a:rPr sz="1050" b="0">
                 <a:solidFill>
@@ -16037,7 +14420,7 @@
           </a:bodyPr>
           <a:lstStyle/>
           <a:p>
-            <a:pPr algn="l"/>
+            <a:pPr algn="l" marL="228600" indent="-228600"/>
             <a:r>
               <a:rPr sz="1050" b="0">
                 <a:solidFill>
@@ -16225,7 +14608,7 @@
           </a:bodyPr>
           <a:lstStyle/>
           <a:p>
-            <a:pPr algn="l"/>
+            <a:pPr algn="l" marL="228600" indent="-228600"/>
             <a:r>
               <a:rPr sz="1050" b="0">
                 <a:solidFill>
@@ -16409,7 +14792,7 @@
           </a:bodyPr>
           <a:lstStyle/>
           <a:p>
-            <a:pPr algn="l"/>
+            <a:pPr algn="l" marL="228600" indent="-228600"/>
             <a:r>
               <a:rPr sz="1050" b="0">
                 <a:solidFill>
@@ -18592,7 +16975,7 @@
           </a:bodyPr>
           <a:lstStyle/>
           <a:p>
-            <a:pPr>
+            <a:pPr marL="228600" indent="-228600">
               <a:lnSpc>
                 <a:spcPct val="100000"/>
               </a:lnSpc>
@@ -18611,7 +16994,7 @@
             </a:r>
           </a:p>
           <a:p>
-            <a:pPr>
+            <a:pPr marL="228600" indent="-228600">
               <a:lnSpc>
                 <a:spcPct val="100000"/>
               </a:lnSpc>
@@ -18630,7 +17013,7 @@
             </a:r>
           </a:p>
           <a:p>
-            <a:pPr>
+            <a:pPr marL="228600" indent="-228600">
               <a:lnSpc>
                 <a:spcPct val="100000"/>
               </a:lnSpc>
@@ -18649,7 +17032,7 @@
             </a:r>
           </a:p>
           <a:p>
-            <a:pPr>
+            <a:pPr marL="228600" indent="-228600">
               <a:lnSpc>
                 <a:spcPct val="100000"/>
               </a:lnSpc>
@@ -18726,7 +17109,7 @@
           </a:bodyPr>
           <a:lstStyle/>
           <a:p>
-            <a:pPr>
+            <a:pPr marL="228600" indent="-228600">
               <a:lnSpc>
                 <a:spcPct val="100000"/>
               </a:lnSpc>
@@ -18745,7 +17128,7 @@
             </a:r>
           </a:p>
           <a:p>
-            <a:pPr>
+            <a:pPr marL="228600" indent="-228600">
               <a:lnSpc>
                 <a:spcPct val="100000"/>
               </a:lnSpc>
@@ -18764,7 +17147,7 @@
             </a:r>
           </a:p>
           <a:p>
-            <a:pPr>
+            <a:pPr marL="228600" indent="-228600">
               <a:lnSpc>
                 <a:spcPct val="100000"/>
               </a:lnSpc>
@@ -18783,7 +17166,7 @@
             </a:r>
           </a:p>
           <a:p>
-            <a:pPr>
+            <a:pPr marL="228600" indent="-228600">
               <a:lnSpc>
                 <a:spcPct val="100000"/>
               </a:lnSpc>
@@ -24946,7 +23329,7 @@
           </a:bodyPr>
           <a:lstStyle/>
           <a:p>
-            <a:pPr>
+            <a:pPr marL="228600" indent="-228600">
               <a:lnSpc>
                 <a:spcPct val="100000"/>
               </a:lnSpc>
@@ -24965,7 +23348,7 @@
             </a:r>
           </a:p>
           <a:p>
-            <a:pPr>
+            <a:pPr marL="228600" indent="-228600">
               <a:lnSpc>
                 <a:spcPct val="100000"/>
               </a:lnSpc>
@@ -24984,7 +23367,7 @@
             </a:r>
           </a:p>
           <a:p>
-            <a:pPr>
+            <a:pPr marL="228600" indent="-228600">
               <a:lnSpc>
                 <a:spcPct val="100000"/>
               </a:lnSpc>
@@ -27812,7 +26195,7 @@
           </a:bodyPr>
           <a:lstStyle/>
           <a:p>
-            <a:pPr>
+            <a:pPr marL="228600" indent="-228600">
               <a:lnSpc>
                 <a:spcPct val="100000"/>
               </a:lnSpc>
@@ -27831,7 +26214,7 @@
             </a:r>
           </a:p>
           <a:p>
-            <a:pPr>
+            <a:pPr marL="228600" indent="-228600">
               <a:lnSpc>
                 <a:spcPct val="100000"/>
               </a:lnSpc>
@@ -27850,7 +26233,7 @@
             </a:r>
           </a:p>
           <a:p>
-            <a:pPr>
+            <a:pPr marL="228600" indent="-228600">
               <a:lnSpc>
                 <a:spcPct val="100000"/>
               </a:lnSpc>
@@ -27869,7 +26252,7 @@
             </a:r>
           </a:p>
           <a:p>
-            <a:pPr>
+            <a:pPr marL="228600" indent="-228600">
               <a:lnSpc>
                 <a:spcPct val="100000"/>
               </a:lnSpc>

</xml_diff>

<commit_message>
Fix title overlap on cover slide (shrink font to fit 2 lines); revert bullet indent experiment
</commit_message>
<xml_diff>
--- a/Updated_Project.pptx
+++ b/Updated_Project.pptx
@@ -3242,7 +3242,7 @@
           <a:lstStyle/>
           <a:p>
             <a:r>
-              <a:rPr b="1" sz="3800">
+              <a:rPr b="1" sz="2200">
                 <a:latin typeface="Arial"/>
               </a:rPr>
               <a:t>Eco Lifestyle Agent</a:t>
@@ -3250,7 +3250,7 @@
           </a:p>
           <a:p>
             <a:r>
-              <a:rPr b="1" sz="3800">
+              <a:rPr b="1" sz="2200">
                 <a:latin typeface="Arial"/>
               </a:rPr>
               <a:t>with IBM Granite and watsonx Orchestrate</a:t>
@@ -4729,7 +4729,7 @@
           </a:bodyPr>
           <a:lstStyle/>
           <a:p>
-            <a:pPr marL="228600" indent="-228600">
+            <a:pPr>
               <a:lnSpc>
                 <a:spcPct val="100000"/>
               </a:lnSpc>
@@ -4748,7 +4748,7 @@
             </a:r>
           </a:p>
           <a:p>
-            <a:pPr marL="228600" indent="-228600">
+            <a:pPr>
               <a:lnSpc>
                 <a:spcPct val="100000"/>
               </a:lnSpc>
@@ -4767,7 +4767,7 @@
             </a:r>
           </a:p>
           <a:p>
-            <a:pPr marL="228600" indent="-228600">
+            <a:pPr>
               <a:lnSpc>
                 <a:spcPct val="100000"/>
               </a:lnSpc>
@@ -4786,7 +4786,7 @@
             </a:r>
           </a:p>
           <a:p>
-            <a:pPr marL="228600" indent="-228600">
+            <a:pPr>
               <a:lnSpc>
                 <a:spcPct val="100000"/>
               </a:lnSpc>
@@ -11196,7 +11196,7 @@
           </a:bodyPr>
           <a:lstStyle/>
           <a:p>
-            <a:pPr marL="228600" indent="-228600"/>
+            <a:pPr/>
             <a:r>
               <a:rPr sz="1050" b="0">
                 <a:solidFill>
@@ -14420,7 +14420,7 @@
           </a:bodyPr>
           <a:lstStyle/>
           <a:p>
-            <a:pPr algn="l" marL="228600" indent="-228600"/>
+            <a:pPr algn="l"/>
             <a:r>
               <a:rPr sz="1050" b="0">
                 <a:solidFill>
@@ -14608,7 +14608,7 @@
           </a:bodyPr>
           <a:lstStyle/>
           <a:p>
-            <a:pPr algn="l" marL="228600" indent="-228600"/>
+            <a:pPr algn="l"/>
             <a:r>
               <a:rPr sz="1050" b="0">
                 <a:solidFill>
@@ -14792,7 +14792,7 @@
           </a:bodyPr>
           <a:lstStyle/>
           <a:p>
-            <a:pPr algn="l" marL="228600" indent="-228600"/>
+            <a:pPr algn="l"/>
             <a:r>
               <a:rPr sz="1050" b="0">
                 <a:solidFill>
@@ -16975,7 +16975,7 @@
           </a:bodyPr>
           <a:lstStyle/>
           <a:p>
-            <a:pPr marL="228600" indent="-228600">
+            <a:pPr>
               <a:lnSpc>
                 <a:spcPct val="100000"/>
               </a:lnSpc>
@@ -16994,7 +16994,7 @@
             </a:r>
           </a:p>
           <a:p>
-            <a:pPr marL="228600" indent="-228600">
+            <a:pPr>
               <a:lnSpc>
                 <a:spcPct val="100000"/>
               </a:lnSpc>
@@ -17013,7 +17013,7 @@
             </a:r>
           </a:p>
           <a:p>
-            <a:pPr marL="228600" indent="-228600">
+            <a:pPr>
               <a:lnSpc>
                 <a:spcPct val="100000"/>
               </a:lnSpc>
@@ -17032,7 +17032,7 @@
             </a:r>
           </a:p>
           <a:p>
-            <a:pPr marL="228600" indent="-228600">
+            <a:pPr>
               <a:lnSpc>
                 <a:spcPct val="100000"/>
               </a:lnSpc>
@@ -17109,7 +17109,7 @@
           </a:bodyPr>
           <a:lstStyle/>
           <a:p>
-            <a:pPr marL="228600" indent="-228600">
+            <a:pPr>
               <a:lnSpc>
                 <a:spcPct val="100000"/>
               </a:lnSpc>
@@ -17128,7 +17128,7 @@
             </a:r>
           </a:p>
           <a:p>
-            <a:pPr marL="228600" indent="-228600">
+            <a:pPr>
               <a:lnSpc>
                 <a:spcPct val="100000"/>
               </a:lnSpc>
@@ -17147,7 +17147,7 @@
             </a:r>
           </a:p>
           <a:p>
-            <a:pPr marL="228600" indent="-228600">
+            <a:pPr>
               <a:lnSpc>
                 <a:spcPct val="100000"/>
               </a:lnSpc>
@@ -17166,7 +17166,7 @@
             </a:r>
           </a:p>
           <a:p>
-            <a:pPr marL="228600" indent="-228600">
+            <a:pPr>
               <a:lnSpc>
                 <a:spcPct val="100000"/>
               </a:lnSpc>
@@ -23329,7 +23329,7 @@
           </a:bodyPr>
           <a:lstStyle/>
           <a:p>
-            <a:pPr marL="228600" indent="-228600">
+            <a:pPr>
               <a:lnSpc>
                 <a:spcPct val="100000"/>
               </a:lnSpc>
@@ -23348,7 +23348,7 @@
             </a:r>
           </a:p>
           <a:p>
-            <a:pPr marL="228600" indent="-228600">
+            <a:pPr>
               <a:lnSpc>
                 <a:spcPct val="100000"/>
               </a:lnSpc>
@@ -23367,7 +23367,7 @@
             </a:r>
           </a:p>
           <a:p>
-            <a:pPr marL="228600" indent="-228600">
+            <a:pPr>
               <a:lnSpc>
                 <a:spcPct val="100000"/>
               </a:lnSpc>
@@ -26195,7 +26195,7 @@
           </a:bodyPr>
           <a:lstStyle/>
           <a:p>
-            <a:pPr marL="228600" indent="-228600">
+            <a:pPr>
               <a:lnSpc>
                 <a:spcPct val="100000"/>
               </a:lnSpc>
@@ -26214,7 +26214,7 @@
             </a:r>
           </a:p>
           <a:p>
-            <a:pPr marL="228600" indent="-228600">
+            <a:pPr>
               <a:lnSpc>
                 <a:spcPct val="100000"/>
               </a:lnSpc>
@@ -26233,7 +26233,7 @@
             </a:r>
           </a:p>
           <a:p>
-            <a:pPr marL="228600" indent="-228600">
+            <a:pPr>
               <a:lnSpc>
                 <a:spcPct val="100000"/>
               </a:lnSpc>
@@ -26252,7 +26252,7 @@
             </a:r>
           </a:p>
           <a:p>
-            <a:pPr marL="228600" indent="-228600">
+            <a:pPr>
               <a:lnSpc>
                 <a:spcPct val="100000"/>
               </a:lnSpc>

</xml_diff>

<commit_message>
Remove literal bullet glyphs from wrapped paragraphs to match clean flowing-text style
</commit_message>
<xml_diff>
--- a/Updated_Project.pptx
+++ b/Updated_Project.pptx
@@ -4744,7 +4744,7 @@
                 </a:solidFill>
                 <a:latin typeface="Arial"/>
               </a:rPr>
-              <a:t>• Reduces hallucinations by grounding responses in retrieved documents.</a:t>
+              <a:t>Reduces hallucinations by grounding responses in retrieved documents.</a:t>
             </a:r>
           </a:p>
           <a:p>
@@ -4763,7 +4763,7 @@
                 </a:solidFill>
                 <a:latin typeface="Arial"/>
               </a:rPr>
-              <a:t>• Allows updates without retraining the foundation model.</a:t>
+              <a:t>Allows updates without retraining the foundation model.</a:t>
             </a:r>
           </a:p>
           <a:p>
@@ -4782,7 +4782,7 @@
                 </a:solidFill>
                 <a:latin typeface="Arial"/>
               </a:rPr>
-              <a:t>• Supports domain-specific knowledge such as recycling rules and schemes.</a:t>
+              <a:t>Supports domain-specific knowledge such as recycling rules and schemes.</a:t>
             </a:r>
           </a:p>
           <a:p>
@@ -4801,7 +4801,7 @@
                 </a:solidFill>
                 <a:latin typeface="Arial"/>
               </a:rPr>
-              <a:t>• Improves transparency because retrieved evidence can be shown to the user.</a:t>
+              <a:t>Improves transparency because retrieved evidence can be shown to the user.</a:t>
             </a:r>
           </a:p>
         </p:txBody>
@@ -16990,7 +16990,7 @@
                 </a:solidFill>
                 <a:latin typeface="Arial"/>
               </a:rPr>
-              <a:t>• Reliable sustainability information is scattered across government portals, NGO resources, product websites and local service pages.</a:t>
+              <a:t>Reliable sustainability information is scattered across government portals, NGO resources, product websites and local service pages.</a:t>
             </a:r>
           </a:p>
           <a:p>
@@ -17009,7 +17009,7 @@
                 </a:solidFill>
                 <a:latin typeface="Arial"/>
               </a:rPr>
-              <a:t>• Existing search results are generic and do not adapt to user location, lifestyle, budget or habits.</a:t>
+              <a:t>Existing search results are generic and do not adapt to user location, lifestyle, budget or habits.</a:t>
             </a:r>
           </a:p>
           <a:p>
@@ -17028,7 +17028,7 @@
                 </a:solidFill>
                 <a:latin typeface="Arial"/>
               </a:rPr>
-              <a:t>• Users struggle to find local recycling rules, eco-friendly alternatives and government schemes in one place.</a:t>
+              <a:t>Users struggle to find local recycling rules, eco-friendly alternatives and government schemes in one place.</a:t>
             </a:r>
           </a:p>
           <a:p>
@@ -17047,7 +17047,7 @@
                 </a:solidFill>
                 <a:latin typeface="Arial"/>
               </a:rPr>
-              <a:t>• A conversational AI assistant is needed to convert trusted environmental data into practical daily actions.</a:t>
+              <a:t>A conversational AI assistant is needed to convert trusted environmental data into practical daily actions.</a:t>
             </a:r>
           </a:p>
         </p:txBody>
@@ -17124,7 +17124,7 @@
                 </a:solidFill>
                 <a:latin typeface="Arial"/>
               </a:rPr>
-              <a:t>• Build an AI-powered Eco Lifestyle Agent that answers natural language questions.</a:t>
+              <a:t>Build an AI-powered Eco Lifestyle Agent that answers natural language questions.</a:t>
             </a:r>
           </a:p>
           <a:p>
@@ -17143,7 +17143,7 @@
                 </a:solidFill>
                 <a:latin typeface="Arial"/>
               </a:rPr>
-              <a:t>• Use RAG to retrieve trusted environmental information before response generation.</a:t>
+              <a:t>Use RAG to retrieve trusted environmental information before response generation.</a:t>
             </a:r>
           </a:p>
           <a:p>
@@ -17162,7 +17162,7 @@
                 </a:solidFill>
                 <a:latin typeface="Arial"/>
               </a:rPr>
-              <a:t>• Generate personalized, actionable recommendations using IBM Granite Foundation Models.</a:t>
+              <a:t>Generate personalized, actionable recommendations using IBM Granite Foundation Models.</a:t>
             </a:r>
           </a:p>
           <a:p>
@@ -17181,7 +17181,7 @@
                 </a:solidFill>
                 <a:latin typeface="Arial"/>
               </a:rPr>
-              <a:t>• Deploy on IBM Cloud Lite using a scalable, enterprise-ready architecture.</a:t>
+              <a:t>Deploy on IBM Cloud Lite using a scalable, enterprise-ready architecture.</a:t>
             </a:r>
           </a:p>
         </p:txBody>
@@ -23344,7 +23344,7 @@
                 </a:solidFill>
                 <a:latin typeface="Arial"/>
               </a:rPr>
-              <a:t>• IBM watsonx Orchestrate provides a low-code pipeline that connects input, retrieval, reasoning and output components.</a:t>
+              <a:t>IBM watsonx Orchestrate provides a low-code pipeline that connects input, retrieval, reasoning and output components.</a:t>
             </a:r>
           </a:p>
           <a:p>
@@ -23363,7 +23363,7 @@
                 </a:solidFill>
                 <a:latin typeface="Arial"/>
               </a:rPr>
-              <a:t>• The workflow keeps the system modular, transparent and easier to debug during development.</a:t>
+              <a:t>The workflow keeps the system modular, transparent and easier to debug during development.</a:t>
             </a:r>
           </a:p>
           <a:p>
@@ -23382,7 +23382,7 @@
                 </a:solidFill>
                 <a:latin typeface="Arial"/>
               </a:rPr>
-              <a:t>• IBM Granite generates the final response only after relevant environmental context is retrieved.</a:t>
+              <a:t>IBM Granite generates the final response only after relevant environmental context is retrieved.</a:t>
             </a:r>
           </a:p>
         </p:txBody>
@@ -26210,7 +26210,7 @@
                 </a:solidFill>
                 <a:latin typeface="Arial"/>
               </a:rPr>
-              <a:t>• Acts as an intelligent assistant, not only a static FAQ bot.</a:t>
+              <a:t>Acts as an intelligent assistant, not only a static FAQ bot.</a:t>
             </a:r>
           </a:p>
           <a:p>
@@ -26229,7 +26229,7 @@
                 </a:solidFill>
                 <a:latin typeface="Arial"/>
               </a:rPr>
-              <a:t>• Coordinates retrieval, reasoning and response generation as a multi-step workflow.</a:t>
+              <a:t>Coordinates retrieval, reasoning and response generation as a multi-step workflow.</a:t>
             </a:r>
           </a:p>
           <a:p>
@@ -26248,7 +26248,7 @@
                 </a:solidFill>
                 <a:latin typeface="Arial"/>
               </a:rPr>
-              <a:t>• Improves relevance by considering the user’s intent, location and sustainability goal.</a:t>
+              <a:t>Improves relevance by considering the user’s intent, location and sustainability goal.</a:t>
             </a:r>
           </a:p>
           <a:p>
@@ -26267,7 +26267,7 @@
                 </a:solidFill>
                 <a:latin typeface="Arial"/>
               </a:rPr>
-              <a:t>• Supports continuous improvement through feedback and knowledge base updates.</a:t>
+              <a:t>Supports continuous improvement through feedback and knowledge base updates.</a:t>
             </a:r>
           </a:p>
         </p:txBody>

</xml_diff>